<commit_message>
chore(release): 版本同步到 1.18.22 + 文档/PPT 追平 + 收口报告前移
为什么是 1.18.22：v1.18.21 标签已打在 fe5c395（落后收口基线 9 个提交），其 tag 构建的
smoke-test 在 "Frontend release smoke subset" 因 GitHub runner npm ci 连续两次 ECONNRESET
（exit 152）失败，前端冒烟子集未执行 —— 不是代码缺陷。已发布 tag 不改写，故以 1.18.22
对同一批变更 + 收口修复重新出包。

- 版本：node scripts/sync-version.js --write --version 1.18.22（14 个目标文件，--check 通过）
- CHANGELOG：新增 [1.18.22] 段（换 tag 原因 + 三处回归修复 + 两处过时断言按真实契约更新 +
  types/policy.ts 尾换行致 lint 失败）
- README：本版亮点改 1.18.22；全量验证块更新为 2026-10-28 / 后端 14,896 用例 /
  46,243 语句 / 11,560 分支 / 前端 7,384 用例
- docs/INDEX：版本头 + 发布说明改为 RELEASE_NOTES-v1.18.22 + 三份 PPT 版本标记 1.18.22
- docs/04-部署文档/RELEASE_NOTES-v1.18.22.md：由并行会话的 v1.18.21 草案校正而来
  （去掉"CI 全绿"这类尚未发生的断言，改为本地实测结论 + 以 tag 运行记录为准）
- 三份 PPT：页脚/封面 v1.18.22，实测数字 14,896 / 7,384 / 22,280；页数不变 60/44/56
</commit_message>
<xml_diff>
--- a/docs/帮扶管理信息系统-操作培训.pptx
+++ b/docs/帮扶管理信息系统-操作培训.pptx
@@ -5352,7 +5352,7 @@
                 <a:ea typeface="+mn-ea"/>
                 <a:cs typeface="+mn-cs"/>
               </a:rPr>
-              <a:t>V1.18.18 | 2026-10-27 | FastAPI + Vue 3 + Electron + SQLite</a:t>
+              <a:t>V1.18.22 | 2026-10-28 | FastAPI + Vue 3 + Electron + SQLite</a:t>
             </a:r>
           </a:p>
         </p:txBody>
@@ -6185,7 +6185,7 @@
                 <a:ea typeface="+mn-ea"/>
                 <a:cs typeface="+mn-cs"/>
               </a:rPr>
-              <a:t>帮扶管理信息系统 v1.18.18</a:t>
+              <a:t>帮扶管理信息系统 v1.18.22</a:t>
             </a:r>
           </a:p>
         </p:txBody>
@@ -8153,7 +8153,7 @@
                 <a:ea typeface="+mn-ea"/>
                 <a:cs typeface="+mn-cs"/>
               </a:rPr>
-              <a:t>帮扶管理信息系统 v1.18.18</a:t>
+              <a:t>帮扶管理信息系统 v1.18.22</a:t>
             </a:r>
           </a:p>
         </p:txBody>
@@ -9040,7 +9040,7 @@
                 <a:ea typeface="+mn-ea"/>
                 <a:cs typeface="+mn-cs"/>
               </a:rPr>
-              <a:t>帮扶管理信息系统 v1.18.18</a:t>
+              <a:t>帮扶管理信息系统 v1.18.22</a:t>
             </a:r>
           </a:p>
         </p:txBody>
@@ -10005,7 +10005,7 @@
                 <a:ea typeface="+mn-ea"/>
                 <a:cs typeface="+mn-cs"/>
               </a:rPr>
-              <a:t>帮扶管理信息系统 v1.18.18</a:t>
+              <a:t>帮扶管理信息系统 v1.18.22</a:t>
             </a:r>
           </a:p>
         </p:txBody>
@@ -10920,7 +10920,7 @@
                 <a:ea typeface="+mn-ea"/>
                 <a:cs typeface="+mn-cs"/>
               </a:rPr>
-              <a:t>帮扶管理信息系统 v1.18.18</a:t>
+              <a:t>帮扶管理信息系统 v1.18.22</a:t>
             </a:r>
           </a:p>
         </p:txBody>
@@ -11875,7 +11875,7 @@
                 <a:ea typeface="+mn-ea"/>
                 <a:cs typeface="+mn-cs"/>
               </a:rPr>
-              <a:t>帮扶管理信息系统 v1.18.18</a:t>
+              <a:t>帮扶管理信息系统 v1.18.22</a:t>
             </a:r>
           </a:p>
         </p:txBody>
@@ -13116,7 +13116,7 @@
                 <a:ea typeface="+mn-ea"/>
                 <a:cs typeface="+mn-cs"/>
               </a:rPr>
-              <a:t>帮扶管理信息系统 v1.18.18</a:t>
+              <a:t>帮扶管理信息系统 v1.18.22</a:t>
             </a:r>
           </a:p>
         </p:txBody>
@@ -14237,7 +14237,7 @@
                 <a:ea typeface="+mn-ea"/>
                 <a:cs typeface="+mn-cs"/>
               </a:rPr>
-              <a:t>帮扶管理信息系统 v1.18.18</a:t>
+              <a:t>帮扶管理信息系统 v1.18.22</a:t>
             </a:r>
           </a:p>
         </p:txBody>
@@ -15136,7 +15136,7 @@
                 <a:ea typeface="+mn-ea"/>
                 <a:cs typeface="+mn-cs"/>
               </a:rPr>
-              <a:t>帮扶管理信息系统 v1.18.18</a:t>
+              <a:t>帮扶管理信息系统 v1.18.22</a:t>
             </a:r>
           </a:p>
         </p:txBody>
@@ -16545,7 +16545,7 @@
                 <a:ea typeface="+mn-ea"/>
                 <a:cs typeface="+mn-cs"/>
               </a:rPr>
-              <a:t>帮扶管理信息系统 v1.18.18</a:t>
+              <a:t>帮扶管理信息系统 v1.18.22</a:t>
             </a:r>
           </a:p>
         </p:txBody>
@@ -17600,7 +17600,7 @@
                 <a:ea typeface="+mn-ea"/>
                 <a:cs typeface="+mn-cs"/>
               </a:rPr>
-              <a:t>帮扶管理信息系统 v1.18.18</a:t>
+              <a:t>帮扶管理信息系统 v1.18.22</a:t>
             </a:r>
           </a:p>
         </p:txBody>
@@ -19622,7 +19622,7 @@
                 <a:ea typeface="+mn-ea"/>
                 <a:cs typeface="+mn-cs"/>
               </a:rPr>
-              <a:t>帮扶管理信息系统 v1.18.18</a:t>
+              <a:t>帮扶管理信息系统 v1.18.22</a:t>
             </a:r>
           </a:p>
         </p:txBody>
@@ -20759,7 +20759,7 @@
                 <a:ea typeface="+mn-ea"/>
                 <a:cs typeface="+mn-cs"/>
               </a:rPr>
-              <a:t>帮扶管理信息系统 v1.18.18</a:t>
+              <a:t>帮扶管理信息系统 v1.18.22</a:t>
             </a:r>
           </a:p>
         </p:txBody>
@@ -21672,7 +21672,7 @@
                 <a:ea typeface="+mn-ea"/>
                 <a:cs typeface="+mn-cs"/>
               </a:rPr>
-              <a:t>帮扶管理信息系统 v1.18.18</a:t>
+              <a:t>帮扶管理信息系统 v1.18.22</a:t>
             </a:r>
           </a:p>
         </p:txBody>
@@ -22627,7 +22627,7 @@
                 <a:ea typeface="+mn-ea"/>
                 <a:cs typeface="+mn-cs"/>
               </a:rPr>
-              <a:t>帮扶管理信息系统 v1.18.18</a:t>
+              <a:t>帮扶管理信息系统 v1.18.22</a:t>
             </a:r>
           </a:p>
         </p:txBody>
@@ -23592,7 +23592,7 @@
                 <a:ea typeface="+mn-ea"/>
                 <a:cs typeface="+mn-cs"/>
               </a:rPr>
-              <a:t>帮扶管理信息系统 v1.18.18</a:t>
+              <a:t>帮扶管理信息系统 v1.18.22</a:t>
             </a:r>
           </a:p>
         </p:txBody>
@@ -24833,7 +24833,7 @@
                 <a:ea typeface="+mn-ea"/>
                 <a:cs typeface="+mn-cs"/>
               </a:rPr>
-              <a:t>帮扶管理信息系统 v1.18.18</a:t>
+              <a:t>帮扶管理信息系统 v1.18.22</a:t>
             </a:r>
           </a:p>
         </p:txBody>
@@ -25748,7 +25748,7 @@
                 <a:ea typeface="+mn-ea"/>
                 <a:cs typeface="+mn-cs"/>
               </a:rPr>
-              <a:t>帮扶管理信息系统 v1.18.18</a:t>
+              <a:t>帮扶管理信息系统 v1.18.22</a:t>
             </a:r>
           </a:p>
         </p:txBody>
@@ -26489,7 +26489,7 @@
                 <a:ea typeface="+mn-ea"/>
                 <a:cs typeface="+mn-cs"/>
               </a:rPr>
-              <a:t>帮扶管理信息系统 v1.18.18</a:t>
+              <a:t>帮扶管理信息系统 v1.18.22</a:t>
             </a:r>
           </a:p>
         </p:txBody>
@@ -27596,7 +27596,7 @@
                 <a:ea typeface="+mn-ea"/>
                 <a:cs typeface="+mn-cs"/>
               </a:rPr>
-              <a:t>帮扶管理信息系统 v1.18.18</a:t>
+              <a:t>帮扶管理信息系统 v1.18.22</a:t>
             </a:r>
           </a:p>
         </p:txBody>
@@ -28561,7 +28561,7 @@
                 <a:ea typeface="+mn-ea"/>
                 <a:cs typeface="+mn-cs"/>
               </a:rPr>
-              <a:t>帮扶管理信息系统 v1.18.18</a:t>
+              <a:t>帮扶管理信息系统 v1.18.22</a:t>
             </a:r>
           </a:p>
         </p:txBody>
@@ -29370,7 +29370,7 @@
                 <a:ea typeface="+mn-ea"/>
                 <a:cs typeface="+mn-cs"/>
               </a:rPr>
-              <a:t>帮扶管理信息系统 v1.18.18</a:t>
+              <a:t>帮扶管理信息系统 v1.18.22</a:t>
             </a:r>
           </a:p>
         </p:txBody>
@@ -30545,7 +30545,7 @@
                 <a:ea typeface="+mn-ea"/>
                 <a:cs typeface="+mn-cs"/>
               </a:rPr>
-              <a:t>帮扶管理信息系统 v1.18.18</a:t>
+              <a:t>帮扶管理信息系统 v1.18.22</a:t>
             </a:r>
           </a:p>
         </p:txBody>
@@ -31927,7 +31927,7 @@
                 <a:ea typeface="+mn-ea"/>
                 <a:cs typeface="+mn-cs"/>
               </a:rPr>
-              <a:t>帮扶管理信息系统 v1.18.18</a:t>
+              <a:t>帮扶管理信息系统 v1.18.22</a:t>
             </a:r>
           </a:p>
         </p:txBody>
@@ -32736,7 +32736,7 @@
                 <a:ea typeface="+mn-ea"/>
                 <a:cs typeface="+mn-cs"/>
               </a:rPr>
-              <a:t>帮扶管理信息系统 v1.18.18</a:t>
+              <a:t>帮扶管理信息系统 v1.18.22</a:t>
             </a:r>
           </a:p>
         </p:txBody>
@@ -33691,7 +33691,7 @@
                 <a:ea typeface="+mn-ea"/>
                 <a:cs typeface="+mn-cs"/>
               </a:rPr>
-              <a:t>帮扶管理信息系统 v1.18.18</a:t>
+              <a:t>帮扶管理信息系统 v1.18.22</a:t>
             </a:r>
           </a:p>
         </p:txBody>
@@ -34866,7 +34866,7 @@
                 <a:ea typeface="+mn-ea"/>
                 <a:cs typeface="+mn-cs"/>
               </a:rPr>
-              <a:t>帮扶管理信息系统 v1.18.18</a:t>
+              <a:t>帮扶管理信息系统 v1.18.22</a:t>
             </a:r>
           </a:p>
         </p:txBody>
@@ -35675,7 +35675,7 @@
                 <a:ea typeface="+mn-ea"/>
                 <a:cs typeface="+mn-cs"/>
               </a:rPr>
-              <a:t>帮扶管理信息系统 v1.18.18</a:t>
+              <a:t>帮扶管理信息系统 v1.18.22</a:t>
             </a:r>
           </a:p>
         </p:txBody>
@@ -36416,7 +36416,7 @@
                 <a:ea typeface="+mn-ea"/>
                 <a:cs typeface="+mn-cs"/>
               </a:rPr>
-              <a:t>帮扶管理信息系统 v1.18.18</a:t>
+              <a:t>帮扶管理信息系统 v1.18.22</a:t>
             </a:r>
           </a:p>
         </p:txBody>
@@ -37669,7 +37669,7 @@
                 <a:ea typeface="+mn-ea"/>
                 <a:cs typeface="+mn-cs"/>
               </a:rPr>
-              <a:t>帮扶管理信息系统 v1.18.18</a:t>
+              <a:t>帮扶管理信息系统 v1.18.22</a:t>
             </a:r>
           </a:p>
         </p:txBody>
@@ -38478,7 +38478,7 @@
                 <a:ea typeface="+mn-ea"/>
                 <a:cs typeface="+mn-cs"/>
               </a:rPr>
-              <a:t>帮扶管理信息系统 v1.18.18</a:t>
+              <a:t>帮扶管理信息系统 v1.18.22</a:t>
             </a:r>
           </a:p>
         </p:txBody>
@@ -39761,7 +39761,7 @@
                 <a:ea typeface="+mn-ea"/>
                 <a:cs typeface="+mn-cs"/>
               </a:rPr>
-              <a:t>帮扶管理信息系统 v1.18.18</a:t>
+              <a:t>帮扶管理信息系统 v1.18.22</a:t>
             </a:r>
           </a:p>
         </p:txBody>
@@ -40676,7 +40676,7 @@
                 <a:ea typeface="+mn-ea"/>
                 <a:cs typeface="+mn-cs"/>
               </a:rPr>
-              <a:t>帮扶管理信息系统 v1.18.18</a:t>
+              <a:t>帮扶管理信息系统 v1.18.22</a:t>
             </a:r>
           </a:p>
         </p:txBody>
@@ -42146,7 +42146,7 @@
                 <a:ea typeface="+mn-ea"/>
                 <a:cs typeface="+mn-cs"/>
               </a:rPr>
-              <a:t>帮扶管理信息系统 v1.18.18</a:t>
+              <a:t>帮扶管理信息系统 v1.18.22</a:t>
             </a:r>
           </a:p>
         </p:txBody>
@@ -43429,7 +43429,7 @@
                 <a:ea typeface="+mn-ea"/>
                 <a:cs typeface="+mn-cs"/>
               </a:rPr>
-              <a:t>帮扶管理信息系统 v1.18.18</a:t>
+              <a:t>帮扶管理信息系统 v1.18.22</a:t>
             </a:r>
           </a:p>
         </p:txBody>
@@ -44484,7 +44484,7 @@
                 <a:ea typeface="+mn-ea"/>
                 <a:cs typeface="+mn-cs"/>
               </a:rPr>
-              <a:t>帮扶管理信息系统 v1.18.18</a:t>
+              <a:t>帮扶管理信息系统 v1.18.22</a:t>
             </a:r>
           </a:p>
         </p:txBody>
@@ -45383,7 +45383,7 @@
                 <a:ea typeface="+mn-ea"/>
                 <a:cs typeface="+mn-cs"/>
               </a:rPr>
-              <a:t>帮扶管理信息系统 v1.18.18</a:t>
+              <a:t>帮扶管理信息系统 v1.18.22</a:t>
             </a:r>
           </a:p>
         </p:txBody>
@@ -46270,7 +46270,7 @@
                 <a:ea typeface="+mn-ea"/>
                 <a:cs typeface="+mn-cs"/>
               </a:rPr>
-              <a:t>帮扶管理信息系统 v1.18.18</a:t>
+              <a:t>帮扶管理信息系统 v1.18.22</a:t>
             </a:r>
           </a:p>
         </p:txBody>
@@ -47325,7 +47325,7 @@
                 <a:ea typeface="+mn-ea"/>
                 <a:cs typeface="+mn-cs"/>
               </a:rPr>
-              <a:t>帮扶管理信息系统 v1.18.18</a:t>
+              <a:t>帮扶管理信息系统 v1.18.22</a:t>
             </a:r>
           </a:p>
         </p:txBody>
@@ -49588,7 +49588,7 @@
                 <a:ea typeface="+mn-ea"/>
                 <a:cs typeface="+mn-cs"/>
               </a:rPr>
-              <a:t>帮扶管理信息系统 v1.18.18</a:t>
+              <a:t>帮扶管理信息系统 v1.18.22</a:t>
             </a:r>
           </a:p>
         </p:txBody>
@@ -50397,7 +50397,7 @@
                 <a:ea typeface="+mn-ea"/>
                 <a:cs typeface="+mn-cs"/>
               </a:rPr>
-              <a:t>帮扶管理信息系统 v1.18.18</a:t>
+              <a:t>帮扶管理信息系统 v1.18.22</a:t>
             </a:r>
           </a:p>
         </p:txBody>
@@ -51138,7 +51138,7 @@
                 <a:ea typeface="+mn-ea"/>
                 <a:cs typeface="+mn-cs"/>
               </a:rPr>
-              <a:t>帮扶管理信息系统 v1.18.18</a:t>
+              <a:t>帮扶管理信息系统 v1.18.22</a:t>
             </a:r>
           </a:p>
         </p:txBody>
@@ -52053,7 +52053,7 @@
                 <a:ea typeface="+mn-ea"/>
                 <a:cs typeface="+mn-cs"/>
               </a:rPr>
-              <a:t>帮扶管理信息系统 v1.18.18</a:t>
+              <a:t>帮扶管理信息系统 v1.18.22</a:t>
             </a:r>
           </a:p>
         </p:txBody>
@@ -53108,7 +53108,7 @@
                 <a:ea typeface="+mn-ea"/>
                 <a:cs typeface="+mn-cs"/>
               </a:rPr>
-              <a:t>帮扶管理信息系统 v1.18.18</a:t>
+              <a:t>帮扶管理信息系统 v1.18.22</a:t>
             </a:r>
           </a:p>
         </p:txBody>
@@ -54063,7 +54063,7 @@
                 <a:ea typeface="+mn-ea"/>
                 <a:cs typeface="+mn-cs"/>
               </a:rPr>
-              <a:t>帮扶管理信息系统 v1.18.18</a:t>
+              <a:t>帮扶管理信息系统 v1.18.22</a:t>
             </a:r>
           </a:p>
         </p:txBody>
@@ -54804,7 +54804,7 @@
                 <a:ea typeface="+mn-ea"/>
                 <a:cs typeface="+mn-cs"/>
               </a:rPr>
-              <a:t>帮扶管理信息系统 v1.18.18</a:t>
+              <a:t>帮扶管理信息系统 v1.18.22</a:t>
             </a:r>
           </a:p>
         </p:txBody>
@@ -55855,7 +55855,7 @@
                 <a:ea typeface="+mn-ea"/>
                 <a:cs typeface="+mn-cs"/>
               </a:rPr>
-              <a:t>帮扶管理信息系统 v1.18.18</a:t>
+              <a:t>帮扶管理信息系统 v1.18.22</a:t>
             </a:r>
           </a:p>
         </p:txBody>
@@ -56976,7 +56976,7 @@
                 <a:ea typeface="+mn-ea"/>
                 <a:cs typeface="+mn-cs"/>
               </a:rPr>
-              <a:t>帮扶管理信息系统 v1.18.18</a:t>
+              <a:t>帮扶管理信息系统 v1.18.22</a:t>
             </a:r>
           </a:p>
         </p:txBody>
@@ -57941,7 +57941,7 @@
                 <a:ea typeface="+mn-ea"/>
                 <a:cs typeface="+mn-cs"/>
               </a:rPr>
-              <a:t>帮扶管理信息系统 v1.18.18</a:t>
+              <a:t>帮扶管理信息系统 v1.18.22</a:t>
             </a:r>
           </a:p>
         </p:txBody>
@@ -58281,7 +58281,7 @@
                 <a:ea typeface="+mn-ea"/>
                 <a:cs typeface="+mn-cs"/>
               </a:rPr>
-              <a:t>帮扶管理信息系统 v1.18.18 · 仓库：github.com/lzh745200/MRRS · 完整文档见 docs/ 目录</a:t>
+              <a:t>帮扶管理信息系统 v1.18.22 · 仓库：github.com/lzh745200/MRRS · 完整文档见 docs/ 目录</a:t>
             </a:r>
           </a:p>
         </p:txBody>
@@ -58321,7 +58321,7 @@
                 <a:ea typeface="+mn-ea"/>
                 <a:cs typeface="+mn-cs"/>
               </a:rPr>
-              <a:t>V1.18.18 | 2026-10-27</a:t>
+              <a:t>V1.18.22 | 2026-10-28</a:t>
             </a:r>
           </a:p>
         </p:txBody>
@@ -59234,7 +59234,7 @@
                 <a:ea typeface="+mn-ea"/>
                 <a:cs typeface="+mn-cs"/>
               </a:rPr>
-              <a:t>帮扶管理信息系统 v1.18.18</a:t>
+              <a:t>帮扶管理信息系统 v1.18.22</a:t>
             </a:r>
           </a:p>
         </p:txBody>
@@ -60781,7 +60781,7 @@
                 <a:ea typeface="+mn-ea"/>
                 <a:cs typeface="+mn-cs"/>
               </a:rPr>
-              <a:t>帮扶管理信息系统 v1.18.18</a:t>
+              <a:t>帮扶管理信息系统 v1.18.22</a:t>
             </a:r>
           </a:p>
         </p:txBody>
@@ -62224,7 +62224,7 @@
                 <a:ea typeface="+mn-ea"/>
                 <a:cs typeface="+mn-cs"/>
               </a:rPr>
-              <a:t>帮扶管理信息系统 v1.18.18</a:t>
+              <a:t>帮扶管理信息系统 v1.18.22</a:t>
             </a:r>
           </a:p>
         </p:txBody>

</xml_diff>